<commit_message>
Restructured code for geodt and gringarten
Restructured and updated the code to enable use of a new Gringarten based solver, new well models, improve cost models, history match to blue mountain, batch run with a structured grid, and updated documentation to include more detailed validation cases.
</commit_message>
<xml_diff>
--- a/documentation/intro material.pptx
+++ b/documentation/intro material.pptx
@@ -6,6 +6,7 @@
   </p:sldMasterIdLst>
   <p:sldIdLst>
     <p:sldId id="256" r:id="rId2"/>
+    <p:sldId id="257" r:id="rId3"/>
   </p:sldIdLst>
   <p:sldSz cx="12192000" cy="6858000"/>
   <p:notesSz cx="6858000" cy="9144000"/>
@@ -104,6 +105,11 @@
       </a:defRPr>
     </a:lvl9pPr>
   </p:defaultTextStyle>
+  <p:extLst>
+    <p:ext uri="{EFAFB233-063F-42B5-8137-9DF3F51BA10A}">
+      <p15:sldGuideLst xmlns:p15="http://schemas.microsoft.com/office/powerpoint/2012/main"/>
+    </p:ext>
+  </p:extLst>
 </p:presentation>
 </file>
 
@@ -254,7 +260,7 @@
           <a:p>
             <a:fld id="{ED06B613-031A-4CB1-A67F-80615576F29D}" type="datetimeFigureOut">
               <a:rPr lang="en-US" smtClean="0"/>
-              <a:t>8/2/2024</a:t>
+              <a:t>9/27/2025</a:t>
             </a:fld>
             <a:endParaRPr lang="en-US"/>
           </a:p>
@@ -452,7 +458,7 @@
           <a:p>
             <a:fld id="{ED06B613-031A-4CB1-A67F-80615576F29D}" type="datetimeFigureOut">
               <a:rPr lang="en-US" smtClean="0"/>
-              <a:t>8/2/2024</a:t>
+              <a:t>9/27/2025</a:t>
             </a:fld>
             <a:endParaRPr lang="en-US"/>
           </a:p>
@@ -660,7 +666,7 @@
           <a:p>
             <a:fld id="{ED06B613-031A-4CB1-A67F-80615576F29D}" type="datetimeFigureOut">
               <a:rPr lang="en-US" smtClean="0"/>
-              <a:t>8/2/2024</a:t>
+              <a:t>9/27/2025</a:t>
             </a:fld>
             <a:endParaRPr lang="en-US"/>
           </a:p>
@@ -858,7 +864,7 @@
           <a:p>
             <a:fld id="{ED06B613-031A-4CB1-A67F-80615576F29D}" type="datetimeFigureOut">
               <a:rPr lang="en-US" smtClean="0"/>
-              <a:t>8/2/2024</a:t>
+              <a:t>9/27/2025</a:t>
             </a:fld>
             <a:endParaRPr lang="en-US"/>
           </a:p>
@@ -1133,7 +1139,7 @@
           <a:p>
             <a:fld id="{ED06B613-031A-4CB1-A67F-80615576F29D}" type="datetimeFigureOut">
               <a:rPr lang="en-US" smtClean="0"/>
-              <a:t>8/2/2024</a:t>
+              <a:t>9/27/2025</a:t>
             </a:fld>
             <a:endParaRPr lang="en-US"/>
           </a:p>
@@ -1398,7 +1404,7 @@
           <a:p>
             <a:fld id="{ED06B613-031A-4CB1-A67F-80615576F29D}" type="datetimeFigureOut">
               <a:rPr lang="en-US" smtClean="0"/>
-              <a:t>8/2/2024</a:t>
+              <a:t>9/27/2025</a:t>
             </a:fld>
             <a:endParaRPr lang="en-US"/>
           </a:p>
@@ -1810,7 +1816,7 @@
           <a:p>
             <a:fld id="{ED06B613-031A-4CB1-A67F-80615576F29D}" type="datetimeFigureOut">
               <a:rPr lang="en-US" smtClean="0"/>
-              <a:t>8/2/2024</a:t>
+              <a:t>9/27/2025</a:t>
             </a:fld>
             <a:endParaRPr lang="en-US"/>
           </a:p>
@@ -1951,7 +1957,7 @@
           <a:p>
             <a:fld id="{ED06B613-031A-4CB1-A67F-80615576F29D}" type="datetimeFigureOut">
               <a:rPr lang="en-US" smtClean="0"/>
-              <a:t>8/2/2024</a:t>
+              <a:t>9/27/2025</a:t>
             </a:fld>
             <a:endParaRPr lang="en-US"/>
           </a:p>
@@ -2064,7 +2070,7 @@
           <a:p>
             <a:fld id="{ED06B613-031A-4CB1-A67F-80615576F29D}" type="datetimeFigureOut">
               <a:rPr lang="en-US" smtClean="0"/>
-              <a:t>8/2/2024</a:t>
+              <a:t>9/27/2025</a:t>
             </a:fld>
             <a:endParaRPr lang="en-US"/>
           </a:p>
@@ -2375,7 +2381,7 @@
           <a:p>
             <a:fld id="{ED06B613-031A-4CB1-A67F-80615576F29D}" type="datetimeFigureOut">
               <a:rPr lang="en-US" smtClean="0"/>
-              <a:t>8/2/2024</a:t>
+              <a:t>9/27/2025</a:t>
             </a:fld>
             <a:endParaRPr lang="en-US"/>
           </a:p>
@@ -2663,7 +2669,7 @@
           <a:p>
             <a:fld id="{ED06B613-031A-4CB1-A67F-80615576F29D}" type="datetimeFigureOut">
               <a:rPr lang="en-US" smtClean="0"/>
-              <a:t>8/2/2024</a:t>
+              <a:t>9/27/2025</a:t>
             </a:fld>
             <a:endParaRPr lang="en-US"/>
           </a:p>
@@ -2904,7 +2910,7 @@
           <a:p>
             <a:fld id="{ED06B613-031A-4CB1-A67F-80615576F29D}" type="datetimeFigureOut">
               <a:rPr lang="en-US" smtClean="0"/>
-              <a:t>8/2/2024</a:t>
+              <a:t>9/27/2025</a:t>
             </a:fld>
             <a:endParaRPr lang="en-US"/>
           </a:p>
@@ -3905,6 +3911,1105 @@
 </p:sld>
 </file>
 
+<file path=ppt/slides/slide2.xml><?xml version="1.0" encoding="utf-8"?>
+<p:sld xmlns:a="http://schemas.openxmlformats.org/drawingml/2006/main" xmlns:r="http://schemas.openxmlformats.org/officeDocument/2006/relationships" xmlns:p="http://schemas.openxmlformats.org/presentationml/2006/main">
+  <p:cSld>
+    <p:spTree>
+      <p:nvGrpSpPr>
+        <p:cNvPr id="1" name="">
+          <a:extLst>
+            <a:ext uri="{FF2B5EF4-FFF2-40B4-BE49-F238E27FC236}">
+              <a16:creationId xmlns:a16="http://schemas.microsoft.com/office/drawing/2014/main" id="{4930C129-E3CA-6081-ADBD-989B2443A37B}"/>
+            </a:ext>
+          </a:extLst>
+        </p:cNvPr>
+        <p:cNvGrpSpPr/>
+        <p:nvPr/>
+      </p:nvGrpSpPr>
+      <p:grpSpPr>
+        <a:xfrm>
+          <a:off x="0" y="0"/>
+          <a:ext cx="0" cy="0"/>
+          <a:chOff x="0" y="0"/>
+          <a:chExt cx="0" cy="0"/>
+        </a:xfrm>
+      </p:grpSpPr>
+      <p:sp>
+        <p:nvSpPr>
+          <p:cNvPr id="2" name="Rectangle 1">
+            <a:extLst>
+              <a:ext uri="{FF2B5EF4-FFF2-40B4-BE49-F238E27FC236}">
+                <a16:creationId xmlns:a16="http://schemas.microsoft.com/office/drawing/2014/main" id="{78B9A9B7-E466-3F8C-4209-2599EB019421}"/>
+              </a:ext>
+            </a:extLst>
+          </p:cNvPr>
+          <p:cNvSpPr/>
+          <p:nvPr/>
+        </p:nvSpPr>
+        <p:spPr>
+          <a:xfrm>
+            <a:off x="3943563" y="986317"/>
+            <a:ext cx="4512067" cy="454888"/>
+          </a:xfrm>
+          <a:prstGeom prst="rect">
+            <a:avLst/>
+          </a:prstGeom>
+          <a:solidFill>
+            <a:schemeClr val="accent6">
+              <a:lumMod val="20000"/>
+              <a:lumOff val="80000"/>
+            </a:schemeClr>
+          </a:solidFill>
+          <a:ln w="12700">
+            <a:solidFill>
+              <a:schemeClr val="tx1"/>
+            </a:solidFill>
+          </a:ln>
+        </p:spPr>
+        <p:style>
+          <a:lnRef idx="2">
+            <a:schemeClr val="accent1">
+              <a:shade val="15000"/>
+            </a:schemeClr>
+          </a:lnRef>
+          <a:fillRef idx="1">
+            <a:schemeClr val="accent1"/>
+          </a:fillRef>
+          <a:effectRef idx="0">
+            <a:schemeClr val="accent1"/>
+          </a:effectRef>
+          <a:fontRef idx="minor">
+            <a:schemeClr val="lt1"/>
+          </a:fontRef>
+        </p:style>
+        <p:txBody>
+          <a:bodyPr rtlCol="0" anchor="ctr"/>
+          <a:lstStyle/>
+          <a:p>
+            <a:pPr algn="ctr"/>
+            <a:r>
+              <a:rPr lang="en-US" dirty="0">
+                <a:solidFill>
+                  <a:schemeClr val="tx1"/>
+                </a:solidFill>
+              </a:rPr>
+              <a:t>Model Settings (*.set)</a:t>
+            </a:r>
+          </a:p>
+        </p:txBody>
+      </p:sp>
+      <p:sp>
+        <p:nvSpPr>
+          <p:cNvPr id="3" name="Rectangle 2">
+            <a:extLst>
+              <a:ext uri="{FF2B5EF4-FFF2-40B4-BE49-F238E27FC236}">
+                <a16:creationId xmlns:a16="http://schemas.microsoft.com/office/drawing/2014/main" id="{8F744E2D-3E22-2F06-7381-B13275946019}"/>
+              </a:ext>
+            </a:extLst>
+          </p:cNvPr>
+          <p:cNvSpPr/>
+          <p:nvPr/>
+        </p:nvSpPr>
+        <p:spPr>
+          <a:xfrm>
+            <a:off x="3943563" y="1776956"/>
+            <a:ext cx="4512067" cy="454888"/>
+          </a:xfrm>
+          <a:prstGeom prst="rect">
+            <a:avLst/>
+          </a:prstGeom>
+          <a:solidFill>
+            <a:schemeClr val="accent6">
+              <a:lumMod val="20000"/>
+              <a:lumOff val="80000"/>
+            </a:schemeClr>
+          </a:solidFill>
+          <a:ln w="12700">
+            <a:solidFill>
+              <a:schemeClr val="tx1"/>
+            </a:solidFill>
+          </a:ln>
+        </p:spPr>
+        <p:style>
+          <a:lnRef idx="2">
+            <a:schemeClr val="accent1">
+              <a:shade val="15000"/>
+            </a:schemeClr>
+          </a:lnRef>
+          <a:fillRef idx="1">
+            <a:schemeClr val="accent1"/>
+          </a:fillRef>
+          <a:effectRef idx="0">
+            <a:schemeClr val="accent1"/>
+          </a:effectRef>
+          <a:fontRef idx="minor">
+            <a:schemeClr val="lt1"/>
+          </a:fontRef>
+        </p:style>
+        <p:txBody>
+          <a:bodyPr rtlCol="0" anchor="ctr"/>
+          <a:lstStyle/>
+          <a:p>
+            <a:pPr algn="ctr"/>
+            <a:r>
+              <a:rPr lang="en-US" dirty="0">
+                <a:solidFill>
+                  <a:schemeClr val="tx1"/>
+                </a:solidFill>
+              </a:rPr>
+              <a:t>Fractures and Wells</a:t>
+            </a:r>
+          </a:p>
+        </p:txBody>
+      </p:sp>
+      <p:cxnSp>
+        <p:nvCxnSpPr>
+          <p:cNvPr id="12" name="Straight Arrow Connector 11">
+            <a:extLst>
+              <a:ext uri="{FF2B5EF4-FFF2-40B4-BE49-F238E27FC236}">
+                <a16:creationId xmlns:a16="http://schemas.microsoft.com/office/drawing/2014/main" id="{6008FE5A-716D-ECC8-0CDA-5E9C1797B2C2}"/>
+              </a:ext>
+            </a:extLst>
+          </p:cNvPr>
+          <p:cNvCxnSpPr>
+            <a:stCxn id="2" idx="2"/>
+            <a:endCxn id="3" idx="0"/>
+          </p:cNvCxnSpPr>
+          <p:nvPr/>
+        </p:nvCxnSpPr>
+        <p:spPr>
+          <a:xfrm>
+            <a:off x="6199597" y="1441205"/>
+            <a:ext cx="0" cy="335751"/>
+          </a:xfrm>
+          <a:prstGeom prst="straightConnector1">
+            <a:avLst/>
+          </a:prstGeom>
+          <a:ln w="38100">
+            <a:solidFill>
+              <a:schemeClr val="tx1"/>
+            </a:solidFill>
+            <a:tailEnd type="triangle"/>
+          </a:ln>
+        </p:spPr>
+        <p:style>
+          <a:lnRef idx="2">
+            <a:schemeClr val="accent1"/>
+          </a:lnRef>
+          <a:fillRef idx="0">
+            <a:schemeClr val="accent1"/>
+          </a:fillRef>
+          <a:effectRef idx="1">
+            <a:schemeClr val="accent1"/>
+          </a:effectRef>
+          <a:fontRef idx="minor">
+            <a:schemeClr val="tx1"/>
+          </a:fontRef>
+        </p:style>
+      </p:cxnSp>
+      <p:sp>
+        <p:nvSpPr>
+          <p:cNvPr id="13" name="Rectangle 12">
+            <a:extLst>
+              <a:ext uri="{FF2B5EF4-FFF2-40B4-BE49-F238E27FC236}">
+                <a16:creationId xmlns:a16="http://schemas.microsoft.com/office/drawing/2014/main" id="{1743C347-3DDB-D92C-4A53-8E30C0954B15}"/>
+              </a:ext>
+            </a:extLst>
+          </p:cNvPr>
+          <p:cNvSpPr/>
+          <p:nvPr/>
+        </p:nvSpPr>
+        <p:spPr>
+          <a:xfrm>
+            <a:off x="3943563" y="2567596"/>
+            <a:ext cx="4512067" cy="454888"/>
+          </a:xfrm>
+          <a:prstGeom prst="rect">
+            <a:avLst/>
+          </a:prstGeom>
+          <a:solidFill>
+            <a:schemeClr val="accent6">
+              <a:lumMod val="20000"/>
+              <a:lumOff val="80000"/>
+            </a:schemeClr>
+          </a:solidFill>
+          <a:ln w="12700">
+            <a:solidFill>
+              <a:schemeClr val="tx1"/>
+            </a:solidFill>
+          </a:ln>
+        </p:spPr>
+        <p:style>
+          <a:lnRef idx="2">
+            <a:schemeClr val="accent1">
+              <a:shade val="15000"/>
+            </a:schemeClr>
+          </a:lnRef>
+          <a:fillRef idx="1">
+            <a:schemeClr val="accent1"/>
+          </a:fillRef>
+          <a:effectRef idx="0">
+            <a:schemeClr val="accent1"/>
+          </a:effectRef>
+          <a:fontRef idx="minor">
+            <a:schemeClr val="lt1"/>
+          </a:fontRef>
+        </p:style>
+        <p:txBody>
+          <a:bodyPr rtlCol="0" anchor="ctr"/>
+          <a:lstStyle/>
+          <a:p>
+            <a:pPr algn="ctr"/>
+            <a:r>
+              <a:rPr lang="en-US" dirty="0">
+                <a:solidFill>
+                  <a:schemeClr val="tx1"/>
+                </a:solidFill>
+              </a:rPr>
+              <a:t>Geomechanics</a:t>
+            </a:r>
+          </a:p>
+        </p:txBody>
+      </p:sp>
+      <p:cxnSp>
+        <p:nvCxnSpPr>
+          <p:cNvPr id="14" name="Straight Arrow Connector 13">
+            <a:extLst>
+              <a:ext uri="{FF2B5EF4-FFF2-40B4-BE49-F238E27FC236}">
+                <a16:creationId xmlns:a16="http://schemas.microsoft.com/office/drawing/2014/main" id="{BDA79C86-1578-AD62-7AC7-5FA190175E9B}"/>
+              </a:ext>
+            </a:extLst>
+          </p:cNvPr>
+          <p:cNvCxnSpPr>
+            <a:endCxn id="13" idx="0"/>
+          </p:cNvCxnSpPr>
+          <p:nvPr/>
+        </p:nvCxnSpPr>
+        <p:spPr>
+          <a:xfrm>
+            <a:off x="6199597" y="2231845"/>
+            <a:ext cx="0" cy="335751"/>
+          </a:xfrm>
+          <a:prstGeom prst="straightConnector1">
+            <a:avLst/>
+          </a:prstGeom>
+          <a:ln w="38100">
+            <a:solidFill>
+              <a:schemeClr val="tx1"/>
+            </a:solidFill>
+            <a:tailEnd type="triangle"/>
+          </a:ln>
+        </p:spPr>
+        <p:style>
+          <a:lnRef idx="2">
+            <a:schemeClr val="accent1"/>
+          </a:lnRef>
+          <a:fillRef idx="0">
+            <a:schemeClr val="accent1"/>
+          </a:fillRef>
+          <a:effectRef idx="1">
+            <a:schemeClr val="accent1"/>
+          </a:effectRef>
+          <a:fontRef idx="minor">
+            <a:schemeClr val="tx1"/>
+          </a:fontRef>
+        </p:style>
+      </p:cxnSp>
+      <p:sp>
+        <p:nvSpPr>
+          <p:cNvPr id="15" name="Rectangle 14">
+            <a:extLst>
+              <a:ext uri="{FF2B5EF4-FFF2-40B4-BE49-F238E27FC236}">
+                <a16:creationId xmlns:a16="http://schemas.microsoft.com/office/drawing/2014/main" id="{693FC993-CA7B-02B4-125C-4FA79E61DF88}"/>
+              </a:ext>
+            </a:extLst>
+          </p:cNvPr>
+          <p:cNvSpPr/>
+          <p:nvPr/>
+        </p:nvSpPr>
+        <p:spPr>
+          <a:xfrm>
+            <a:off x="3943563" y="3358235"/>
+            <a:ext cx="4512067" cy="454888"/>
+          </a:xfrm>
+          <a:prstGeom prst="rect">
+            <a:avLst/>
+          </a:prstGeom>
+          <a:solidFill>
+            <a:schemeClr val="accent6">
+              <a:lumMod val="20000"/>
+              <a:lumOff val="80000"/>
+            </a:schemeClr>
+          </a:solidFill>
+          <a:ln w="12700">
+            <a:solidFill>
+              <a:schemeClr val="tx1"/>
+            </a:solidFill>
+          </a:ln>
+        </p:spPr>
+        <p:style>
+          <a:lnRef idx="2">
+            <a:schemeClr val="accent1">
+              <a:shade val="15000"/>
+            </a:schemeClr>
+          </a:lnRef>
+          <a:fillRef idx="1">
+            <a:schemeClr val="accent1"/>
+          </a:fillRef>
+          <a:effectRef idx="0">
+            <a:schemeClr val="accent1"/>
+          </a:effectRef>
+          <a:fontRef idx="minor">
+            <a:schemeClr val="lt1"/>
+          </a:fontRef>
+        </p:style>
+        <p:txBody>
+          <a:bodyPr rtlCol="0" anchor="ctr"/>
+          <a:lstStyle/>
+          <a:p>
+            <a:pPr algn="ctr"/>
+            <a:r>
+              <a:rPr lang="en-US" dirty="0">
+                <a:solidFill>
+                  <a:schemeClr val="tx1"/>
+                </a:solidFill>
+              </a:rPr>
+              <a:t>Flow Solver</a:t>
+            </a:r>
+          </a:p>
+        </p:txBody>
+      </p:sp>
+      <p:cxnSp>
+        <p:nvCxnSpPr>
+          <p:cNvPr id="16" name="Straight Arrow Connector 15">
+            <a:extLst>
+              <a:ext uri="{FF2B5EF4-FFF2-40B4-BE49-F238E27FC236}">
+                <a16:creationId xmlns:a16="http://schemas.microsoft.com/office/drawing/2014/main" id="{12194F16-F758-3095-A316-910284114CB0}"/>
+              </a:ext>
+            </a:extLst>
+          </p:cNvPr>
+          <p:cNvCxnSpPr>
+            <a:endCxn id="15" idx="0"/>
+          </p:cNvCxnSpPr>
+          <p:nvPr/>
+        </p:nvCxnSpPr>
+        <p:spPr>
+          <a:xfrm>
+            <a:off x="6199597" y="3022484"/>
+            <a:ext cx="0" cy="335751"/>
+          </a:xfrm>
+          <a:prstGeom prst="straightConnector1">
+            <a:avLst/>
+          </a:prstGeom>
+          <a:ln w="38100">
+            <a:solidFill>
+              <a:schemeClr val="tx1"/>
+            </a:solidFill>
+            <a:tailEnd type="triangle"/>
+          </a:ln>
+        </p:spPr>
+        <p:style>
+          <a:lnRef idx="2">
+            <a:schemeClr val="accent1"/>
+          </a:lnRef>
+          <a:fillRef idx="0">
+            <a:schemeClr val="accent1"/>
+          </a:fillRef>
+          <a:effectRef idx="1">
+            <a:schemeClr val="accent1"/>
+          </a:effectRef>
+          <a:fontRef idx="minor">
+            <a:schemeClr val="tx1"/>
+          </a:fontRef>
+        </p:style>
+      </p:cxnSp>
+      <p:sp>
+        <p:nvSpPr>
+          <p:cNvPr id="17" name="Rectangle 16">
+            <a:extLst>
+              <a:ext uri="{FF2B5EF4-FFF2-40B4-BE49-F238E27FC236}">
+                <a16:creationId xmlns:a16="http://schemas.microsoft.com/office/drawing/2014/main" id="{7D05D45F-EE55-BA57-E047-169D198B5E32}"/>
+              </a:ext>
+            </a:extLst>
+          </p:cNvPr>
+          <p:cNvSpPr/>
+          <p:nvPr/>
+        </p:nvSpPr>
+        <p:spPr>
+          <a:xfrm>
+            <a:off x="3943563" y="4148875"/>
+            <a:ext cx="4512067" cy="454888"/>
+          </a:xfrm>
+          <a:prstGeom prst="rect">
+            <a:avLst/>
+          </a:prstGeom>
+          <a:solidFill>
+            <a:schemeClr val="accent6">
+              <a:lumMod val="20000"/>
+              <a:lumOff val="80000"/>
+            </a:schemeClr>
+          </a:solidFill>
+          <a:ln w="12700">
+            <a:solidFill>
+              <a:schemeClr val="tx1"/>
+            </a:solidFill>
+          </a:ln>
+        </p:spPr>
+        <p:style>
+          <a:lnRef idx="2">
+            <a:schemeClr val="accent1">
+              <a:shade val="15000"/>
+            </a:schemeClr>
+          </a:lnRef>
+          <a:fillRef idx="1">
+            <a:schemeClr val="accent1"/>
+          </a:fillRef>
+          <a:effectRef idx="0">
+            <a:schemeClr val="accent1"/>
+          </a:effectRef>
+          <a:fontRef idx="minor">
+            <a:schemeClr val="lt1"/>
+          </a:fontRef>
+        </p:style>
+        <p:txBody>
+          <a:bodyPr rtlCol="0" anchor="ctr"/>
+          <a:lstStyle/>
+          <a:p>
+            <a:pPr algn="ctr"/>
+            <a:r>
+              <a:rPr lang="en-US" dirty="0">
+                <a:solidFill>
+                  <a:schemeClr val="tx1"/>
+                </a:solidFill>
+              </a:rPr>
+              <a:t>Heat Solver</a:t>
+            </a:r>
+          </a:p>
+        </p:txBody>
+      </p:sp>
+      <p:cxnSp>
+        <p:nvCxnSpPr>
+          <p:cNvPr id="18" name="Straight Arrow Connector 17">
+            <a:extLst>
+              <a:ext uri="{FF2B5EF4-FFF2-40B4-BE49-F238E27FC236}">
+                <a16:creationId xmlns:a16="http://schemas.microsoft.com/office/drawing/2014/main" id="{6E18ED0F-B64A-8B32-4E3F-8C56DEE17A90}"/>
+              </a:ext>
+            </a:extLst>
+          </p:cNvPr>
+          <p:cNvCxnSpPr>
+            <a:endCxn id="17" idx="0"/>
+          </p:cNvCxnSpPr>
+          <p:nvPr/>
+        </p:nvCxnSpPr>
+        <p:spPr>
+          <a:xfrm>
+            <a:off x="6199597" y="3813124"/>
+            <a:ext cx="0" cy="335751"/>
+          </a:xfrm>
+          <a:prstGeom prst="straightConnector1">
+            <a:avLst/>
+          </a:prstGeom>
+          <a:ln w="38100">
+            <a:solidFill>
+              <a:schemeClr val="tx1"/>
+            </a:solidFill>
+            <a:tailEnd type="triangle"/>
+          </a:ln>
+        </p:spPr>
+        <p:style>
+          <a:lnRef idx="2">
+            <a:schemeClr val="accent1"/>
+          </a:lnRef>
+          <a:fillRef idx="0">
+            <a:schemeClr val="accent1"/>
+          </a:fillRef>
+          <a:effectRef idx="1">
+            <a:schemeClr val="accent1"/>
+          </a:effectRef>
+          <a:fontRef idx="minor">
+            <a:schemeClr val="tx1"/>
+          </a:fontRef>
+        </p:style>
+      </p:cxnSp>
+      <p:sp>
+        <p:nvSpPr>
+          <p:cNvPr id="19" name="Rectangle 18">
+            <a:extLst>
+              <a:ext uri="{FF2B5EF4-FFF2-40B4-BE49-F238E27FC236}">
+                <a16:creationId xmlns:a16="http://schemas.microsoft.com/office/drawing/2014/main" id="{9558FB12-529B-3581-6645-F30126AC76F9}"/>
+              </a:ext>
+            </a:extLst>
+          </p:cNvPr>
+          <p:cNvSpPr/>
+          <p:nvPr/>
+        </p:nvSpPr>
+        <p:spPr>
+          <a:xfrm>
+            <a:off x="3943563" y="4939514"/>
+            <a:ext cx="4512067" cy="454888"/>
+          </a:xfrm>
+          <a:prstGeom prst="rect">
+            <a:avLst/>
+          </a:prstGeom>
+          <a:solidFill>
+            <a:schemeClr val="tx2">
+              <a:lumMod val="10000"/>
+              <a:lumOff val="90000"/>
+            </a:schemeClr>
+          </a:solidFill>
+          <a:ln w="12700">
+            <a:solidFill>
+              <a:schemeClr val="tx1"/>
+            </a:solidFill>
+          </a:ln>
+        </p:spPr>
+        <p:style>
+          <a:lnRef idx="2">
+            <a:schemeClr val="accent1">
+              <a:shade val="15000"/>
+            </a:schemeClr>
+          </a:lnRef>
+          <a:fillRef idx="1">
+            <a:schemeClr val="accent1"/>
+          </a:fillRef>
+          <a:effectRef idx="0">
+            <a:schemeClr val="accent1"/>
+          </a:effectRef>
+          <a:fontRef idx="minor">
+            <a:schemeClr val="lt1"/>
+          </a:fontRef>
+        </p:style>
+        <p:txBody>
+          <a:bodyPr rtlCol="0" anchor="ctr"/>
+          <a:lstStyle/>
+          <a:p>
+            <a:pPr algn="ctr"/>
+            <a:r>
+              <a:rPr lang="en-US" dirty="0">
+                <a:solidFill>
+                  <a:schemeClr val="tx1"/>
+                </a:solidFill>
+              </a:rPr>
+              <a:t>Power Conversion</a:t>
+            </a:r>
+          </a:p>
+        </p:txBody>
+      </p:sp>
+      <p:cxnSp>
+        <p:nvCxnSpPr>
+          <p:cNvPr id="20" name="Straight Arrow Connector 19">
+            <a:extLst>
+              <a:ext uri="{FF2B5EF4-FFF2-40B4-BE49-F238E27FC236}">
+                <a16:creationId xmlns:a16="http://schemas.microsoft.com/office/drawing/2014/main" id="{A0E202CC-D67A-611D-F5CE-F4B6C6CB09A0}"/>
+              </a:ext>
+            </a:extLst>
+          </p:cNvPr>
+          <p:cNvCxnSpPr>
+            <a:endCxn id="19" idx="0"/>
+          </p:cNvCxnSpPr>
+          <p:nvPr/>
+        </p:nvCxnSpPr>
+        <p:spPr>
+          <a:xfrm>
+            <a:off x="6199597" y="4603763"/>
+            <a:ext cx="0" cy="335751"/>
+          </a:xfrm>
+          <a:prstGeom prst="straightConnector1">
+            <a:avLst/>
+          </a:prstGeom>
+          <a:ln w="38100">
+            <a:solidFill>
+              <a:schemeClr val="tx1"/>
+            </a:solidFill>
+            <a:tailEnd type="triangle"/>
+          </a:ln>
+        </p:spPr>
+        <p:style>
+          <a:lnRef idx="2">
+            <a:schemeClr val="accent1"/>
+          </a:lnRef>
+          <a:fillRef idx="0">
+            <a:schemeClr val="accent1"/>
+          </a:fillRef>
+          <a:effectRef idx="1">
+            <a:schemeClr val="accent1"/>
+          </a:effectRef>
+          <a:fontRef idx="minor">
+            <a:schemeClr val="tx1"/>
+          </a:fontRef>
+        </p:style>
+      </p:cxnSp>
+      <p:sp>
+        <p:nvSpPr>
+          <p:cNvPr id="21" name="Rectangle 20">
+            <a:extLst>
+              <a:ext uri="{FF2B5EF4-FFF2-40B4-BE49-F238E27FC236}">
+                <a16:creationId xmlns:a16="http://schemas.microsoft.com/office/drawing/2014/main" id="{33536EC8-65D4-0A80-1C51-70416A73F89B}"/>
+              </a:ext>
+            </a:extLst>
+          </p:cNvPr>
+          <p:cNvSpPr/>
+          <p:nvPr/>
+        </p:nvSpPr>
+        <p:spPr>
+          <a:xfrm>
+            <a:off x="3943563" y="5730154"/>
+            <a:ext cx="4512067" cy="454888"/>
+          </a:xfrm>
+          <a:prstGeom prst="rect">
+            <a:avLst/>
+          </a:prstGeom>
+          <a:solidFill>
+            <a:schemeClr val="tx2">
+              <a:lumMod val="10000"/>
+              <a:lumOff val="90000"/>
+            </a:schemeClr>
+          </a:solidFill>
+          <a:ln w="12700">
+            <a:solidFill>
+              <a:schemeClr val="tx1"/>
+            </a:solidFill>
+          </a:ln>
+        </p:spPr>
+        <p:style>
+          <a:lnRef idx="2">
+            <a:schemeClr val="accent1">
+              <a:shade val="15000"/>
+            </a:schemeClr>
+          </a:lnRef>
+          <a:fillRef idx="1">
+            <a:schemeClr val="accent1"/>
+          </a:fillRef>
+          <a:effectRef idx="0">
+            <a:schemeClr val="accent1"/>
+          </a:effectRef>
+          <a:fontRef idx="minor">
+            <a:schemeClr val="lt1"/>
+          </a:fontRef>
+        </p:style>
+        <p:txBody>
+          <a:bodyPr rtlCol="0" anchor="ctr"/>
+          <a:lstStyle/>
+          <a:p>
+            <a:pPr algn="ctr"/>
+            <a:r>
+              <a:rPr lang="en-US" dirty="0">
+                <a:solidFill>
+                  <a:schemeClr val="tx1"/>
+                </a:solidFill>
+              </a:rPr>
+              <a:t>Outputs (*.csv, *.</a:t>
+            </a:r>
+            <a:r>
+              <a:rPr lang="en-US" dirty="0" err="1">
+                <a:solidFill>
+                  <a:schemeClr val="tx1"/>
+                </a:solidFill>
+              </a:rPr>
+              <a:t>vtk</a:t>
+            </a:r>
+            <a:r>
+              <a:rPr lang="en-US" dirty="0">
+                <a:solidFill>
+                  <a:schemeClr val="tx1"/>
+                </a:solidFill>
+              </a:rPr>
+              <a:t>, *.</a:t>
+            </a:r>
+            <a:r>
+              <a:rPr lang="en-US" dirty="0" err="1">
+                <a:solidFill>
+                  <a:schemeClr val="tx1"/>
+                </a:solidFill>
+              </a:rPr>
+              <a:t>geodt</a:t>
+            </a:r>
+            <a:r>
+              <a:rPr lang="en-US" dirty="0">
+                <a:solidFill>
+                  <a:schemeClr val="tx1"/>
+                </a:solidFill>
+              </a:rPr>
+              <a:t>)</a:t>
+            </a:r>
+          </a:p>
+        </p:txBody>
+      </p:sp>
+      <p:cxnSp>
+        <p:nvCxnSpPr>
+          <p:cNvPr id="22" name="Straight Arrow Connector 21">
+            <a:extLst>
+              <a:ext uri="{FF2B5EF4-FFF2-40B4-BE49-F238E27FC236}">
+                <a16:creationId xmlns:a16="http://schemas.microsoft.com/office/drawing/2014/main" id="{1F6310F0-37B7-4C93-F648-0E56C7D3D564}"/>
+              </a:ext>
+            </a:extLst>
+          </p:cNvPr>
+          <p:cNvCxnSpPr>
+            <a:endCxn id="21" idx="0"/>
+          </p:cNvCxnSpPr>
+          <p:nvPr/>
+        </p:nvCxnSpPr>
+        <p:spPr>
+          <a:xfrm>
+            <a:off x="6199597" y="5394403"/>
+            <a:ext cx="0" cy="335751"/>
+          </a:xfrm>
+          <a:prstGeom prst="straightConnector1">
+            <a:avLst/>
+          </a:prstGeom>
+          <a:ln w="38100">
+            <a:solidFill>
+              <a:schemeClr val="tx1"/>
+            </a:solidFill>
+            <a:tailEnd type="triangle"/>
+          </a:ln>
+        </p:spPr>
+        <p:style>
+          <a:lnRef idx="2">
+            <a:schemeClr val="accent1"/>
+          </a:lnRef>
+          <a:fillRef idx="0">
+            <a:schemeClr val="accent1"/>
+          </a:fillRef>
+          <a:effectRef idx="1">
+            <a:schemeClr val="accent1"/>
+          </a:effectRef>
+          <a:fontRef idx="minor">
+            <a:schemeClr val="tx1"/>
+          </a:fontRef>
+        </p:style>
+      </p:cxnSp>
+      <p:sp>
+        <p:nvSpPr>
+          <p:cNvPr id="25" name="Arc 24">
+            <a:extLst>
+              <a:ext uri="{FF2B5EF4-FFF2-40B4-BE49-F238E27FC236}">
+                <a16:creationId xmlns:a16="http://schemas.microsoft.com/office/drawing/2014/main" id="{8D8FB4D7-6E93-30A6-4872-4330FE626CBB}"/>
+              </a:ext>
+            </a:extLst>
+          </p:cNvPr>
+          <p:cNvSpPr/>
+          <p:nvPr/>
+        </p:nvSpPr>
+        <p:spPr>
+          <a:xfrm>
+            <a:off x="4068567" y="3446977"/>
+            <a:ext cx="297951" cy="297951"/>
+          </a:xfrm>
+          <a:prstGeom prst="arc">
+            <a:avLst>
+              <a:gd name="adj1" fmla="val 19859003"/>
+              <a:gd name="adj2" fmla="val 18718431"/>
+            </a:avLst>
+          </a:prstGeom>
+          <a:ln w="38100">
+            <a:solidFill>
+              <a:schemeClr val="tx1"/>
+            </a:solidFill>
+            <a:tailEnd type="triangle"/>
+          </a:ln>
+        </p:spPr>
+        <p:style>
+          <a:lnRef idx="2">
+            <a:schemeClr val="accent1"/>
+          </a:lnRef>
+          <a:fillRef idx="0">
+            <a:schemeClr val="accent1"/>
+          </a:fillRef>
+          <a:effectRef idx="1">
+            <a:schemeClr val="accent1"/>
+          </a:effectRef>
+          <a:fontRef idx="minor">
+            <a:schemeClr val="tx1"/>
+          </a:fontRef>
+        </p:style>
+        <p:txBody>
+          <a:bodyPr rtlCol="0" anchor="ctr"/>
+          <a:lstStyle/>
+          <a:p>
+            <a:pPr algn="ctr"/>
+            <a:endParaRPr lang="en-US"/>
+          </a:p>
+        </p:txBody>
+      </p:sp>
+      <p:sp>
+        <p:nvSpPr>
+          <p:cNvPr id="26" name="Arc 25">
+            <a:extLst>
+              <a:ext uri="{FF2B5EF4-FFF2-40B4-BE49-F238E27FC236}">
+                <a16:creationId xmlns:a16="http://schemas.microsoft.com/office/drawing/2014/main" id="{98E17B2E-3FFA-CD70-70D9-1AFE58E4599C}"/>
+              </a:ext>
+            </a:extLst>
+          </p:cNvPr>
+          <p:cNvSpPr/>
+          <p:nvPr/>
+        </p:nvSpPr>
+        <p:spPr>
+          <a:xfrm>
+            <a:off x="4068567" y="4233893"/>
+            <a:ext cx="297951" cy="297951"/>
+          </a:xfrm>
+          <a:prstGeom prst="arc">
+            <a:avLst>
+              <a:gd name="adj1" fmla="val 19859003"/>
+              <a:gd name="adj2" fmla="val 18718431"/>
+            </a:avLst>
+          </a:prstGeom>
+          <a:ln w="38100">
+            <a:solidFill>
+              <a:schemeClr val="tx1"/>
+            </a:solidFill>
+            <a:tailEnd type="triangle"/>
+          </a:ln>
+        </p:spPr>
+        <p:style>
+          <a:lnRef idx="2">
+            <a:schemeClr val="accent1"/>
+          </a:lnRef>
+          <a:fillRef idx="0">
+            <a:schemeClr val="accent1"/>
+          </a:fillRef>
+          <a:effectRef idx="1">
+            <a:schemeClr val="accent1"/>
+          </a:effectRef>
+          <a:fontRef idx="minor">
+            <a:schemeClr val="tx1"/>
+          </a:fontRef>
+        </p:style>
+        <p:txBody>
+          <a:bodyPr rtlCol="0" anchor="ctr"/>
+          <a:lstStyle/>
+          <a:p>
+            <a:pPr algn="ctr"/>
+            <a:endParaRPr lang="en-US"/>
+          </a:p>
+        </p:txBody>
+      </p:sp>
+      <p:sp>
+        <p:nvSpPr>
+          <p:cNvPr id="27" name="Left Bracket 26">
+            <a:extLst>
+              <a:ext uri="{FF2B5EF4-FFF2-40B4-BE49-F238E27FC236}">
+                <a16:creationId xmlns:a16="http://schemas.microsoft.com/office/drawing/2014/main" id="{E8FB24E8-4545-3431-E12A-FB2C85C7B655}"/>
+              </a:ext>
+            </a:extLst>
+          </p:cNvPr>
+          <p:cNvSpPr/>
+          <p:nvPr/>
+        </p:nvSpPr>
+        <p:spPr>
+          <a:xfrm>
+            <a:off x="3634480" y="2034283"/>
+            <a:ext cx="308225" cy="1520574"/>
+          </a:xfrm>
+          <a:prstGeom prst="leftBracket">
+            <a:avLst>
+              <a:gd name="adj" fmla="val 88333"/>
+            </a:avLst>
+          </a:prstGeom>
+          <a:ln w="38100">
+            <a:solidFill>
+              <a:srgbClr val="000000"/>
+            </a:solidFill>
+            <a:tailEnd type="triangle"/>
+          </a:ln>
+        </p:spPr>
+        <p:style>
+          <a:lnRef idx="2">
+            <a:schemeClr val="accent1"/>
+          </a:lnRef>
+          <a:fillRef idx="0">
+            <a:schemeClr val="accent1"/>
+          </a:fillRef>
+          <a:effectRef idx="1">
+            <a:schemeClr val="accent1"/>
+          </a:effectRef>
+          <a:fontRef idx="minor">
+            <a:schemeClr val="tx1"/>
+          </a:fontRef>
+        </p:style>
+        <p:txBody>
+          <a:bodyPr rtlCol="0" anchor="ctr"/>
+          <a:lstStyle/>
+          <a:p>
+            <a:pPr algn="ctr"/>
+            <a:endParaRPr lang="en-US"/>
+          </a:p>
+        </p:txBody>
+      </p:sp>
+      <p:sp>
+        <p:nvSpPr>
+          <p:cNvPr id="28" name="Left Bracket 27">
+            <a:extLst>
+              <a:ext uri="{FF2B5EF4-FFF2-40B4-BE49-F238E27FC236}">
+                <a16:creationId xmlns:a16="http://schemas.microsoft.com/office/drawing/2014/main" id="{C7E836DE-8DBE-C98B-3EA9-94ADD0883F6C}"/>
+              </a:ext>
+            </a:extLst>
+          </p:cNvPr>
+          <p:cNvSpPr/>
+          <p:nvPr/>
+        </p:nvSpPr>
+        <p:spPr>
+          <a:xfrm>
+            <a:off x="3634480" y="3647325"/>
+            <a:ext cx="308225" cy="719191"/>
+          </a:xfrm>
+          <a:prstGeom prst="leftBracket">
+            <a:avLst>
+              <a:gd name="adj" fmla="val 88333"/>
+            </a:avLst>
+          </a:prstGeom>
+          <a:ln w="38100">
+            <a:solidFill>
+              <a:srgbClr val="000000"/>
+            </a:solidFill>
+            <a:tailEnd type="triangle"/>
+          </a:ln>
+        </p:spPr>
+        <p:style>
+          <a:lnRef idx="2">
+            <a:schemeClr val="accent1"/>
+          </a:lnRef>
+          <a:fillRef idx="0">
+            <a:schemeClr val="accent1"/>
+          </a:fillRef>
+          <a:effectRef idx="1">
+            <a:schemeClr val="accent1"/>
+          </a:effectRef>
+          <a:fontRef idx="minor">
+            <a:schemeClr val="tx1"/>
+          </a:fontRef>
+        </p:style>
+        <p:txBody>
+          <a:bodyPr rtlCol="0" anchor="ctr"/>
+          <a:lstStyle/>
+          <a:p>
+            <a:pPr algn="ctr"/>
+            <a:endParaRPr lang="en-US"/>
+          </a:p>
+        </p:txBody>
+      </p:sp>
+      <p:sp>
+        <p:nvSpPr>
+          <p:cNvPr id="29" name="Rectangle 28">
+            <a:extLst>
+              <a:ext uri="{FF2B5EF4-FFF2-40B4-BE49-F238E27FC236}">
+                <a16:creationId xmlns:a16="http://schemas.microsoft.com/office/drawing/2014/main" id="{C3AE7632-0EB2-1387-C278-7DAE70907D66}"/>
+              </a:ext>
+            </a:extLst>
+          </p:cNvPr>
+          <p:cNvSpPr/>
+          <p:nvPr/>
+        </p:nvSpPr>
+        <p:spPr>
+          <a:xfrm>
+            <a:off x="3942705" y="195677"/>
+            <a:ext cx="4512067" cy="454888"/>
+          </a:xfrm>
+          <a:prstGeom prst="rect">
+            <a:avLst/>
+          </a:prstGeom>
+          <a:solidFill>
+            <a:schemeClr val="tx2">
+              <a:lumMod val="10000"/>
+              <a:lumOff val="90000"/>
+            </a:schemeClr>
+          </a:solidFill>
+          <a:ln w="12700">
+            <a:solidFill>
+              <a:schemeClr val="tx1"/>
+            </a:solidFill>
+          </a:ln>
+        </p:spPr>
+        <p:style>
+          <a:lnRef idx="2">
+            <a:schemeClr val="accent1">
+              <a:shade val="15000"/>
+            </a:schemeClr>
+          </a:lnRef>
+          <a:fillRef idx="1">
+            <a:schemeClr val="accent1"/>
+          </a:fillRef>
+          <a:effectRef idx="0">
+            <a:schemeClr val="accent1"/>
+          </a:effectRef>
+          <a:fontRef idx="minor">
+            <a:schemeClr val="lt1"/>
+          </a:fontRef>
+        </p:style>
+        <p:txBody>
+          <a:bodyPr rtlCol="0" anchor="ctr"/>
+          <a:lstStyle/>
+          <a:p>
+            <a:pPr algn="ctr"/>
+            <a:r>
+              <a:rPr lang="en-US" dirty="0">
+                <a:solidFill>
+                  <a:schemeClr val="tx1"/>
+                </a:solidFill>
+              </a:rPr>
+              <a:t>Model Settings (*.set)</a:t>
+            </a:r>
+          </a:p>
+        </p:txBody>
+      </p:sp>
+      <p:cxnSp>
+        <p:nvCxnSpPr>
+          <p:cNvPr id="30" name="Straight Arrow Connector 29">
+            <a:extLst>
+              <a:ext uri="{FF2B5EF4-FFF2-40B4-BE49-F238E27FC236}">
+                <a16:creationId xmlns:a16="http://schemas.microsoft.com/office/drawing/2014/main" id="{5D326AD5-FA1C-EA72-F5D3-694AAAD9084D}"/>
+              </a:ext>
+            </a:extLst>
+          </p:cNvPr>
+          <p:cNvCxnSpPr>
+            <a:stCxn id="29" idx="2"/>
+          </p:cNvCxnSpPr>
+          <p:nvPr/>
+        </p:nvCxnSpPr>
+        <p:spPr>
+          <a:xfrm>
+            <a:off x="6198739" y="650565"/>
+            <a:ext cx="0" cy="335751"/>
+          </a:xfrm>
+          <a:prstGeom prst="straightConnector1">
+            <a:avLst/>
+          </a:prstGeom>
+          <a:ln w="38100">
+            <a:solidFill>
+              <a:schemeClr val="tx1"/>
+            </a:solidFill>
+            <a:tailEnd type="triangle"/>
+          </a:ln>
+        </p:spPr>
+        <p:style>
+          <a:lnRef idx="2">
+            <a:schemeClr val="accent1"/>
+          </a:lnRef>
+          <a:fillRef idx="0">
+            <a:schemeClr val="accent1"/>
+          </a:fillRef>
+          <a:effectRef idx="1">
+            <a:schemeClr val="accent1"/>
+          </a:effectRef>
+          <a:fontRef idx="minor">
+            <a:schemeClr val="tx1"/>
+          </a:fontRef>
+        </p:style>
+      </p:cxnSp>
+    </p:spTree>
+    <p:extLst>
+      <p:ext uri="{BB962C8B-B14F-4D97-AF65-F5344CB8AC3E}">
+        <p14:creationId xmlns:p14="http://schemas.microsoft.com/office/powerpoint/2010/main" val="776878785"/>
+      </p:ext>
+    </p:extLst>
+  </p:cSld>
+  <p:clrMapOvr>
+    <a:masterClrMapping/>
+  </p:clrMapOvr>
+</p:sld>
+</file>
+
 <file path=ppt/theme/theme1.xml><?xml version="1.0" encoding="utf-8"?>
 <a:theme xmlns:a="http://schemas.openxmlformats.org/drawingml/2006/main" name="Office Theme">
   <a:themeElements>

</xml_diff>